<commit_message>
feat: comprehensive platform improvements - extraction methods, benchmarks, and UI
</commit_message>
<xml_diff>
--- a/backend/tests/fixtures/sample.pptx
+++ b/backend/tests/fixtures/sample.pptx
@@ -3106,7 +3106,7 @@
           <a:lstStyle/>
           <a:p>
             <a:r>
-              <a:t>Test Presentation</a:t>
+              <a:t>Project Update</a:t>
             </a:r>
           </a:p>
         </p:txBody>
@@ -3127,7 +3127,7 @@
           <a:lstStyle/>
           <a:p>
             <a:r>
-              <a:t>E2E Testing for Phase 1</a:t>
+              <a:t>Q3 2024 Review</a:t>
             </a:r>
           </a:p>
         </p:txBody>
@@ -3166,7 +3166,7 @@
           <a:lstStyle/>
           <a:p>
             <a:r>
-              <a:t>Content Slide</a:t>
+              <a:t>Budget Overview</a:t>
             </a:r>
           </a:p>
         </p:txBody>
@@ -3187,7 +3187,17 @@
           <a:lstStyle/>
           <a:p>
             <a:r>
-              <a:t>This is test content for PPTX parsing.</a:t>
+              <a:t>Allocated: $500,000</a:t>
+            </a:r>
+          </a:p>
+          <a:p>
+            <a:r>
+              <a:t>Spent: $425,000</a:t>
+            </a:r>
+          </a:p>
+          <a:p>
+            <a:r>
+              <a:t>Remaining: $75,000</a:t>
             </a:r>
           </a:p>
         </p:txBody>
@@ -3226,7 +3236,7 @@
           <a:lstStyle/>
           <a:p>
             <a:r>
-              <a:t>Another Slide</a:t>
+              <a:t>Timeline</a:t>
             </a:r>
           </a:p>
         </p:txBody>
@@ -3247,7 +3257,17 @@
           <a:lstStyle/>
           <a:p>
             <a:r>
-              <a:t>Additional content for testing purposes.</a:t>
+              <a:t>Phase 1: Complete (Jan-Mar)</a:t>
+            </a:r>
+          </a:p>
+          <a:p>
+            <a:r>
+              <a:t>Phase 2: In Progress (Apr-Jun)</a:t>
+            </a:r>
+          </a:p>
+          <a:p>
+            <a:r>
+              <a:t>Phase 3: Planned (Jul-Sep)</a:t>
             </a:r>
           </a:p>
         </p:txBody>

</xml_diff>